<commit_message>
Refresh overview deck, genericize SRE skill examples, and de-flake banner drag smoke
- Overview deck and its build script refreshed for the September 2026 AI & ML
  community call (15 models, current capabilities, Aug 22 - Sep 20 usage).
- SRE agent skill examples use a generic retail order platform instead of a
  specific engagement.
- release-smoke: poll the dragged banner position instead of reading it once,
  removing a race between the last synthetic mousemove and the React commit.

Co-authored-by: Copilot <223556219+Copilot@users.noreply.github.com>
</commit_message>
<xml_diff>
--- a/decks/azure-diagram-builder-overview.pptx
+++ b/decks/azure-diagram-builder-overview.pptx
@@ -141,7 +141,7 @@
                 </a:solidFill>
                 <a:latin typeface="Segoe UI"/>
               </a:rPr>
-              <a:t>Monthly active users</a:t>
+              <a:t>Feature events — independent counts, not a funnel</a:t>
             </a:r>
           </a:p>
         </c:rich>
@@ -153,7 +153,7 @@
     <c:plotArea>
       <c:layout/>
       <c:barChart>
-        <c:barDir val="col"/>
+        <c:barDir val="bar"/>
         <c:grouping val="clustered"/>
         <c:varyColors val="0"/>
         <c:ser>
@@ -165,7 +165,7 @@
               <c:strCache>
                 <c:ptCount val="1"/>
                 <c:pt idx="0">
-                  <c:v>Active users</c:v>
+                  <c:v>Events</c:v>
                 </c:pt>
               </c:strCache>
             </c:strRef>
@@ -203,21 +203,27 @@
           </c:dLbls>
           <c:cat>
             <c:multiLvlStrRef>
-              <c:f>Sheet1!$A$2:$A$5</c:f>
+              <c:f>Sheet1!$A$2:$A$7</c:f>
               <c:multiLvlStrCache>
-                <c:ptCount val="4"/>
+                <c:ptCount val="6"/>
                 <c:lvl>
                   <c:pt idx="0">
-                    <c:v>Mar</c:v>
+                    <c:v>Architectures</c:v>
                   </c:pt>
                   <c:pt idx="1">
-                    <c:v>Apr</c:v>
+                    <c:v>Exports</c:v>
                   </c:pt>
                   <c:pt idx="2">
-                    <c:v>May</c:v>
+                    <c:v>WAF validations</c:v>
                   </c:pt>
                   <c:pt idx="3">
-                    <c:v>Jun (partial)</c:v>
+                    <c:v>Region changes</c:v>
+                  </c:pt>
+                  <c:pt idx="4">
+                    <c:v>Image imports</c:v>
+                  </c:pt>
+                  <c:pt idx="5">
+                    <c:v>Deploy guides</c:v>
                   </c:pt>
                 </c:lvl>
               </c:multiLvlStrCache>
@@ -225,21 +231,27 @@
           </c:cat>
           <c:val>
             <c:numRef>
-              <c:f>Sheet1!$B$2:$B$5</c:f>
+              <c:f>Sheet1!$B$2:$B$7</c:f>
               <c:numCache>
                 <c:formatCode>General</c:formatCode>
-                <c:ptCount val="4"/>
+                <c:ptCount val="6"/>
                 <c:pt idx="0">
-                  <c:v>5</c:v>
+                  <c:v>1376</c:v>
                 </c:pt>
                 <c:pt idx="1">
-                  <c:v>10</c:v>
+                  <c:v>832</c:v>
                 </c:pt>
                 <c:pt idx="2">
-                  <c:v>109</c:v>
+                  <c:v>253</c:v>
                 </c:pt>
                 <c:pt idx="3">
-                  <c:v>155</c:v>
+                  <c:v>201</c:v>
+                </c:pt>
+                <c:pt idx="4">
+                  <c:v>90</c:v>
+                </c:pt>
+                <c:pt idx="5">
+                  <c:v>40</c:v>
                 </c:pt>
               </c:numCache>
             </c:numRef>
@@ -269,7 +281,7 @@
           <c:showBubbleSize val="0"/>
           <c:showLeaderLines val="0"/>
         </c:dLbls>
-        <c:gapWidth val="60"/>
+        <c:gapWidth val="45"/>
         <c:overlap val="0"/>
         <c:axId val="2094734554"/>
         <c:axId val="2094734552"/>
@@ -281,11 +293,11 @@
           <c:orientation val="minMax"/>
         </c:scaling>
         <c:delete val="0"/>
-        <c:axPos val="b"/>
+        <c:axPos val="l"/>
         <c:numFmt formatCode="General" sourceLinked="1"/>
         <c:majorTickMark val="out"/>
         <c:minorTickMark val="none"/>
-        <c:tickLblPos val="low"/>
+        <c:tickLblPos val="nextTo"/>
         <c:spPr>
           <a:ln w="12700" cap="flat">
             <a:solidFill>
@@ -322,12 +334,12 @@
           <c:orientation val="minMax"/>
         </c:scaling>
         <c:delete val="0"/>
-        <c:axPos val="l"/>
+        <c:axPos val="b"/>
         <c:majorGridlines>
           <c:spPr>
-            <a:ln w="6350" cap="flat">
+            <a:ln w="12700" cap="flat">
               <a:solidFill>
-                <a:srgbClr val="D9E2EC"/>
+                <a:srgbClr val="B8C7D9"/>
               </a:solidFill>
               <a:prstDash val="solid"/>
               <a:round/>
@@ -337,7 +349,7 @@
         <c:numFmt formatCode="General" sourceLinked="0"/>
         <c:majorTickMark val="out"/>
         <c:minorTickMark val="none"/>
-        <c:tickLblPos val="nextTo"/>
+        <c:tickLblPos val="low"/>
         <c:spPr>
           <a:ln w="12700" cap="flat">
             <a:solidFill>
@@ -418,7 +430,7 @@
                 </a:solidFill>
                 <a:latin typeface="Segoe UI"/>
               </a:rPr>
-              <a:t>Exports by format</a:t>
+              <a:t>Selected export events · latest complete 30 days</a:t>
             </a:r>
           </a:p>
         </c:rich>
@@ -494,19 +506,19 @@
                     <c:v>PowerPoint</c:v>
                   </c:pt>
                   <c:pt idx="3">
+                    <c:v>SVG</c:v>
+                  </c:pt>
+                  <c:pt idx="4">
+                    <c:v>Animated SVG</c:v>
+                  </c:pt>
+                  <c:pt idx="5">
                     <c:v>Draw.io</c:v>
                   </c:pt>
-                  <c:pt idx="4">
-                    <c:v>CSV</c:v>
-                  </c:pt>
-                  <c:pt idx="5">
-                    <c:v>SVG</c:v>
-                  </c:pt>
                   <c:pt idx="6">
-                    <c:v>HTML</c:v>
+                    <c:v>Visio</c:v>
                   </c:pt>
                   <c:pt idx="7">
-                    <c:v>IaC bundle</c:v>
+                    <c:v>Workflow animation</c:v>
                   </c:pt>
                 </c:lvl>
               </c:multiLvlStrCache>
@@ -519,28 +531,28 @@
                 <c:formatCode>General</c:formatCode>
                 <c:ptCount val="8"/>
                 <c:pt idx="0">
-                  <c:v>135</c:v>
+                  <c:v>209</c:v>
                 </c:pt>
                 <c:pt idx="1">
-                  <c:v>79</c:v>
+                  <c:v>155</c:v>
                 </c:pt>
                 <c:pt idx="2">
-                  <c:v>43</c:v>
+                  <c:v>81</c:v>
                 </c:pt>
                 <c:pt idx="3">
-                  <c:v>36</c:v>
+                  <c:v>84</c:v>
                 </c:pt>
                 <c:pt idx="4">
-                  <c:v>27</c:v>
+                  <c:v>80</c:v>
                 </c:pt>
                 <c:pt idx="5">
-                  <c:v>23</c:v>
+                  <c:v>59</c:v>
                 </c:pt>
                 <c:pt idx="6">
-                  <c:v>22</c:v>
+                  <c:v>47</c:v>
                 </c:pt>
                 <c:pt idx="7">
-                  <c:v>11</c:v>
+                  <c:v>38</c:v>
                 </c:pt>
               </c:numCache>
             </c:numRef>
@@ -626,9 +638,9 @@
         <c:axPos val="b"/>
         <c:majorGridlines>
           <c:spPr>
-            <a:ln w="6350" cap="flat">
+            <a:ln w="12700" cap="flat">
               <a:solidFill>
-                <a:srgbClr val="D9E2EC"/>
+                <a:srgbClr val="B8C7D9"/>
               </a:solidFill>
               <a:prstDash val="solid"/>
               <a:round/>
@@ -719,7 +731,7 @@
                 </a:solidFill>
                 <a:latin typeface="Segoe UI"/>
               </a:rPr>
-              <a:t>Generation calls by model</a:t>
+              <a:t>Top server model traffic · latest complete 30 days</a:t>
             </a:r>
           </a:p>
         </c:rich>
@@ -786,19 +798,19 @@
                 <c:ptCount val="5"/>
                 <c:lvl>
                   <c:pt idx="0">
-                    <c:v>GPT-5.2</c:v>
+                    <c:v>GPT-5.6 Luna</c:v>
                   </c:pt>
                   <c:pt idx="1">
-                    <c:v>GPT-5.1</c:v>
+                    <c:v>GPT-5.6 Sol</c:v>
                   </c:pt>
                   <c:pt idx="2">
-                    <c:v>GPT-5.4</c:v>
+                    <c:v>GPT-5.6 Terra</c:v>
                   </c:pt>
                   <c:pt idx="3">
-                    <c:v>GPT-5.3 Codex</c:v>
+                    <c:v>GPT-5.4 Mini</c:v>
                   </c:pt>
                   <c:pt idx="4">
-                    <c:v>GPT-5.4 Mini</c:v>
+                    <c:v>DeepSeek V4 Pro</c:v>
                   </c:pt>
                 </c:lvl>
               </c:multiLvlStrCache>
@@ -811,19 +823,19 @@
                 <c:formatCode>General</c:formatCode>
                 <c:ptCount val="5"/>
                 <c:pt idx="0">
-                  <c:v>481</c:v>
+                  <c:v>1559</c:v>
                 </c:pt>
                 <c:pt idx="1">
-                  <c:v>292</c:v>
+                  <c:v>1051</c:v>
                 </c:pt>
                 <c:pt idx="2">
-                  <c:v>227</c:v>
+                  <c:v>69</c:v>
                 </c:pt>
                 <c:pt idx="3">
-                  <c:v>66</c:v>
+                  <c:v>57</c:v>
                 </c:pt>
                 <c:pt idx="4">
-                  <c:v>55</c:v>
+                  <c:v>30</c:v>
                 </c:pt>
               </c:numCache>
             </c:numRef>
@@ -2720,7 +2732,7 @@
                 <a:ea typeface="Segoe UI" pitchFamily="34" charset="-122"/>
                 <a:cs typeface="Segoe UI" pitchFamily="34" charset="-120"/>
               </a:rPr>
-              <a:t>Natural-language prompts → validated, costed, deployable Azure architectures.</a:t>
+              <a:t>From an idea or existing artifact to an editable, validated Azure architecture.</a:t>
             </a:r>
             <a:endParaRPr lang="en-US" sz="2000" dirty="0"/>
           </a:p>
@@ -2735,7 +2747,7 @@
         <p:spPr>
           <a:xfrm>
             <a:off x="822960" y="4526280"/>
-            <a:ext cx="2688336" cy="420624"/>
+            <a:ext cx="4128516" cy="420624"/>
           </a:xfrm>
           <a:prstGeom prst="roundRect">
             <a:avLst>
@@ -2762,7 +2774,7 @@
         <p:spPr>
           <a:xfrm>
             <a:off x="822960" y="4526280"/>
-            <a:ext cx="2688336" cy="420624"/>
+            <a:ext cx="4128516" cy="420624"/>
           </a:xfrm>
           <a:prstGeom prst="rect">
             <a:avLst/>
@@ -2786,7 +2798,7 @@
                 <a:ea typeface="Segoe UI" pitchFamily="34" charset="-122"/>
                 <a:cs typeface="Segoe UI" pitchFamily="34" charset="-120"/>
               </a:rPr>
-              <a:t>714 official Azure icons</a:t>
+              <a:t>Prompt, image, template or Azure import</a:t>
             </a:r>
             <a:endParaRPr lang="en-US" sz="1200" dirty="0"/>
           </a:p>
@@ -2800,8 +2812,8 @@
         </p:nvSpPr>
         <p:spPr>
           <a:xfrm>
-            <a:off x="3739896" y="4526280"/>
-            <a:ext cx="1920240" cy="420624"/>
+            <a:off x="5180076" y="4526280"/>
+            <a:ext cx="1536192" cy="420624"/>
           </a:xfrm>
           <a:prstGeom prst="roundRect">
             <a:avLst>
@@ -2827,8 +2839,8 @@
         </p:nvSpPr>
         <p:spPr>
           <a:xfrm>
-            <a:off x="3739896" y="4526280"/>
-            <a:ext cx="1920240" cy="420624"/>
+            <a:off x="5180076" y="4526280"/>
+            <a:ext cx="1536192" cy="420624"/>
           </a:xfrm>
           <a:prstGeom prst="rect">
             <a:avLst/>
@@ -2852,7 +2864,7 @@
                 <a:ea typeface="Segoe UI" pitchFamily="34" charset="-122"/>
                 <a:cs typeface="Segoe UI" pitchFamily="34" charset="-120"/>
               </a:rPr>
-              <a:t>8 export formats</a:t>
+              <a:t>15 AI models</a:t>
             </a:r>
             <a:endParaRPr lang="en-US" sz="1200" dirty="0"/>
           </a:p>
@@ -2866,8 +2878,8 @@
         </p:nvSpPr>
         <p:spPr>
           <a:xfrm>
-            <a:off x="5888736" y="4526280"/>
-            <a:ext cx="2208276" cy="420624"/>
+            <a:off x="6944868" y="4526280"/>
+            <a:ext cx="1344168" cy="420624"/>
           </a:xfrm>
           <a:prstGeom prst="roundRect">
             <a:avLst>
@@ -2893,8 +2905,8 @@
         </p:nvSpPr>
         <p:spPr>
           <a:xfrm>
-            <a:off x="5888736" y="4526280"/>
-            <a:ext cx="2208276" cy="420624"/>
+            <a:off x="6944868" y="4526280"/>
+            <a:ext cx="1344168" cy="420624"/>
           </a:xfrm>
           <a:prstGeom prst="rect">
             <a:avLst/>
@@ -2918,7 +2930,7 @@
                 <a:ea typeface="Segoe UI" pitchFamily="34" charset="-122"/>
                 <a:cs typeface="Segoe UI" pitchFamily="34" charset="-120"/>
               </a:rPr>
-              <a:t>12+ frontier models</a:t>
+              <a:t>WAF + cost</a:t>
             </a:r>
             <a:endParaRPr lang="en-US" sz="1200" dirty="0"/>
           </a:p>
@@ -2932,8 +2944,8 @@
         </p:nvSpPr>
         <p:spPr>
           <a:xfrm>
-            <a:off x="8325612" y="4526280"/>
-            <a:ext cx="1728216" cy="420624"/>
+            <a:off x="8517636" y="4526280"/>
+            <a:ext cx="1248156" cy="420624"/>
           </a:xfrm>
           <a:prstGeom prst="roundRect">
             <a:avLst>
@@ -2959,8 +2971,8 @@
         </p:nvSpPr>
         <p:spPr>
           <a:xfrm>
-            <a:off x="8325612" y="4526280"/>
-            <a:ext cx="1728216" cy="420624"/>
+            <a:off x="8517636" y="4526280"/>
+            <a:ext cx="1248156" cy="420624"/>
           </a:xfrm>
           <a:prstGeom prst="rect">
             <a:avLst/>
@@ -2984,7 +2996,7 @@
                 <a:ea typeface="Segoe UI" pitchFamily="34" charset="-122"/>
                 <a:cs typeface="Segoe UI" pitchFamily="34" charset="-120"/>
               </a:rPr>
-              <a:t>WAF validation</a:t>
+              <a:t>App + MCP</a:t>
             </a:r>
             <a:endParaRPr lang="en-US" sz="1200" dirty="0"/>
           </a:p>
@@ -3023,7 +3035,7 @@
                 <a:ea typeface="Segoe UI" pitchFamily="34" charset="-122"/>
                 <a:cs typeface="Segoe UI" pitchFamily="34" charset="-120"/>
               </a:rPr>
-              <a:t>Overview · June 2026</a:t>
+              <a:t>AI &amp; ML Community · September 2026</a:t>
             </a:r>
             <a:endParaRPr lang="en-US" sz="1300" dirty="0"/>
           </a:p>
@@ -3054,9 +3066,9 @@
               <a:buNone/>
             </a:pPr>
             <a:r>
-              <a:rPr lang="en-US" sz="900" dirty="0">
-                <a:solidFill>
-                  <a:srgbClr val="5E7799"/>
+              <a:rPr lang="en-US" sz="1000" dirty="0">
+                <a:solidFill>
+                  <a:srgbClr val="9BB0CC"/>
                 </a:solidFill>
                 <a:latin typeface="Segoe UI" pitchFamily="34" charset="0"/>
                 <a:ea typeface="Segoe UI" pitchFamily="34" charset="-122"/>
@@ -3064,7 +3076,7 @@
               </a:rPr>
               <a:t>Azure Architecture Diagram Builder</a:t>
             </a:r>
-            <a:endParaRPr lang="en-US" sz="900" dirty="0"/>
+            <a:endParaRPr lang="en-US" sz="1000" dirty="0"/>
           </a:p>
         </p:txBody>
       </p:sp>
@@ -3093,9 +3105,9 @@
               <a:buNone/>
             </a:pPr>
             <a:r>
-              <a:rPr lang="en-US" sz="900" dirty="0">
-                <a:solidFill>
-                  <a:srgbClr val="5E7799"/>
+              <a:rPr lang="en-US" sz="1000" dirty="0">
+                <a:solidFill>
+                  <a:srgbClr val="9BB0CC"/>
                 </a:solidFill>
                 <a:latin typeface="Segoe UI" pitchFamily="34" charset="0"/>
                 <a:ea typeface="Segoe UI" pitchFamily="34" charset="-122"/>
@@ -3103,7 +3115,7 @@
               </a:rPr>
               <a:t>1</a:t>
             </a:r>
-            <a:endParaRPr lang="en-US" sz="900" dirty="0"/>
+            <a:endParaRPr lang="en-US" sz="1000" dirty="0"/>
           </a:p>
         </p:txBody>
       </p:sp>
@@ -3231,7 +3243,7 @@
                 <a:ea typeface="Segoe UI" pitchFamily="34" charset="-122"/>
                 <a:cs typeface="Segoe UI" pitchFamily="34" charset="-120"/>
               </a:rPr>
-              <a:t>From a sentence to a stakeholder-ready architecture</a:t>
+              <a:t>One workspace from first idea to usable artifact</a:t>
             </a:r>
             <a:endParaRPr lang="en-US" sz="2800" dirty="0"/>
           </a:p>
@@ -3361,7 +3373,7 @@
                 <a:ea typeface="Segoe UI" pitchFamily="34" charset="-122"/>
                 <a:cs typeface="Segoe UI" pitchFamily="34" charset="-120"/>
               </a:rPr>
-              <a:t>Describe</a:t>
+              <a:t>Create</a:t>
             </a:r>
             <a:endParaRPr lang="en-US" sz="1900" dirty="0"/>
           </a:p>
@@ -3400,7 +3412,7 @@
                 <a:ea typeface="Segoe UI" pitchFamily="34" charset="-122"/>
                 <a:cs typeface="Segoe UI" pitchFamily="34" charset="-120"/>
               </a:rPr>
-              <a:t>Type what you want to build in plain English. Pick from 12+ frontier models and a reasoning effort.</a:t>
+              <a:t>Start with a prompt, image, ARM/Bicep/Terraform template, or live Azure resources.</a:t>
             </a:r>
             <a:endParaRPr lang="en-US" sz="1250" dirty="0"/>
           </a:p>
@@ -3530,7 +3542,7 @@
                 <a:ea typeface="Segoe UI" pitchFamily="34" charset="-122"/>
                 <a:cs typeface="Segoe UI" pitchFamily="34" charset="-120"/>
               </a:rPr>
-              <a:t>Generate</a:t>
+              <a:t>Refine</a:t>
             </a:r>
             <a:endParaRPr lang="en-US" sz="1900" dirty="0"/>
           </a:p>
@@ -3569,7 +3581,7 @@
                 <a:ea typeface="Segoe UI" pitchFamily="34" charset="-122"/>
                 <a:cs typeface="Segoe UI" pitchFamily="34" charset="-120"/>
               </a:rPr>
-              <a:t>Get a laid-out diagram with official Azure icons, smart grouping, and editable connections in seconds.</a:t>
+              <a:t>Edit the canvas directly or use Guided Chat for deliberate, minimal architecture changes.</a:t>
             </a:r>
             <a:endParaRPr lang="en-US" sz="1250" dirty="0"/>
           </a:p>
@@ -3738,7 +3750,7 @@
                 <a:ea typeface="Segoe UI" pitchFamily="34" charset="-122"/>
                 <a:cs typeface="Segoe UI" pitchFamily="34" charset="-120"/>
               </a:rPr>
-              <a:t>Run a Well-Architected Framework review that scores the design and surfaces concrete gaps.</a:t>
+              <a:t>Review WAF gaps, compare models, and estimate costs across 14 Azure regions.</a:t>
             </a:r>
             <a:endParaRPr lang="en-US" sz="1250" dirty="0"/>
           </a:p>
@@ -3868,7 +3880,7 @@
                 <a:ea typeface="Segoe UI" pitchFamily="34" charset="-122"/>
                 <a:cs typeface="Segoe UI" pitchFamily="34" charset="-120"/>
               </a:rPr>
-              <a:t>Ship</a:t>
+              <a:t>Deliver</a:t>
             </a:r>
             <a:endParaRPr lang="en-US" sz="1900" dirty="0"/>
           </a:p>
@@ -3907,7 +3919,7 @@
                 <a:ea typeface="Segoe UI" pitchFamily="34" charset="-122"/>
                 <a:cs typeface="Segoe UI" pitchFamily="34" charset="-120"/>
               </a:rPr>
-              <a:t>Export to PNG/SVG/PPTX/Draw.io, generate Bicep deployment guides, and costed multi-region estimates.</a:t>
+              <a:t>Export presentation and engineering artifacts, or expose deterministic design tools through MCP.</a:t>
             </a:r>
             <a:endParaRPr lang="en-US" sz="1250" dirty="0"/>
           </a:p>
@@ -3938,9 +3950,9 @@
               <a:buNone/>
             </a:pPr>
             <a:r>
-              <a:rPr lang="en-US" sz="900" dirty="0">
-                <a:solidFill>
-                  <a:srgbClr val="5E7799"/>
+              <a:rPr lang="en-US" sz="1000" dirty="0">
+                <a:solidFill>
+                  <a:srgbClr val="9BB0CC"/>
                 </a:solidFill>
                 <a:latin typeface="Segoe UI" pitchFamily="34" charset="0"/>
                 <a:ea typeface="Segoe UI" pitchFamily="34" charset="-122"/>
@@ -3948,7 +3960,7 @@
               </a:rPr>
               <a:t>Azure Architecture Diagram Builder</a:t>
             </a:r>
-            <a:endParaRPr lang="en-US" sz="900" dirty="0"/>
+            <a:endParaRPr lang="en-US" sz="1000" dirty="0"/>
           </a:p>
         </p:txBody>
       </p:sp>
@@ -3977,9 +3989,9 @@
               <a:buNone/>
             </a:pPr>
             <a:r>
-              <a:rPr lang="en-US" sz="900" dirty="0">
-                <a:solidFill>
-                  <a:srgbClr val="5E7799"/>
+              <a:rPr lang="en-US" sz="1000" dirty="0">
+                <a:solidFill>
+                  <a:srgbClr val="9BB0CC"/>
                 </a:solidFill>
                 <a:latin typeface="Segoe UI" pitchFamily="34" charset="0"/>
                 <a:ea typeface="Segoe UI" pitchFamily="34" charset="-122"/>
@@ -3987,7 +3999,7 @@
               </a:rPr>
               <a:t>2</a:t>
             </a:r>
-            <a:endParaRPr lang="en-US" sz="900" dirty="0"/>
+            <a:endParaRPr lang="en-US" sz="1000" dirty="0"/>
           </a:p>
         </p:txBody>
       </p:sp>
@@ -4076,7 +4088,7 @@
                 <a:ea typeface="Segoe UI" pitchFamily="34" charset="-122"/>
                 <a:cs typeface="Segoe UI" pitchFamily="34" charset="-120"/>
               </a:rPr>
-              <a:t>IMPACT</a:t>
+              <a:t>CURRENT STATE</a:t>
             </a:r>
             <a:endParaRPr lang="en-US" sz="1200" dirty="0"/>
           </a:p>
@@ -4115,7 +4127,7 @@
                 <a:ea typeface="Segoe UI" pitchFamily="34" charset="-122"/>
                 <a:cs typeface="Segoe UI" pitchFamily="34" charset="-120"/>
               </a:rPr>
-              <a:t>Real adoption, measured — not estimated</a:t>
+              <a:t>A live product, not a diagram-generation demo</a:t>
             </a:r>
             <a:endParaRPr lang="en-US" sz="2800" dirty="0"/>
           </a:p>
@@ -4154,7 +4166,7 @@
                 <a:ea typeface="Segoe UI" pitchFamily="34" charset="-122"/>
                 <a:cs typeface="Segoe UI" pitchFamily="34" charset="-120"/>
               </a:rPr>
-              <a:t>Application Insights + Azure Cost Management · 2026 year-to-date (through 2026-06-22)</a:t>
+              <a:t>Production and source verified on 2026-09-21</a:t>
             </a:r>
             <a:endParaRPr lang="en-US" sz="1200" dirty="0"/>
           </a:p>
@@ -4245,7 +4257,7 @@
                 <a:ea typeface="Segoe UI" pitchFamily="34" charset="-122"/>
                 <a:cs typeface="Segoe UI" pitchFamily="34" charset="-120"/>
               </a:rPr>
-              <a:t>267</a:t>
+              <a:t>v2.0.4</a:t>
             </a:r>
             <a:endParaRPr lang="en-US" sz="3400" dirty="0"/>
           </a:p>
@@ -4284,7 +4296,7 @@
                 <a:ea typeface="Segoe UI" pitchFamily="34" charset="-122"/>
                 <a:cs typeface="Segoe UI" pitchFamily="34" charset="-120"/>
               </a:rPr>
-              <a:t>Unique users</a:t>
+              <a:t>Production web app</a:t>
             </a:r>
             <a:endParaRPr lang="en-US" sz="1200" dirty="0"/>
           </a:p>
@@ -4375,7 +4387,7 @@
                 <a:ea typeface="Segoe UI" pitchFamily="34" charset="-122"/>
                 <a:cs typeface="Segoe UI" pitchFamily="34" charset="-120"/>
               </a:rPr>
-              <a:t>39</a:t>
+              <a:t>15</a:t>
             </a:r>
             <a:endParaRPr lang="en-US" sz="3400" dirty="0"/>
           </a:p>
@@ -4414,7 +4426,7 @@
                 <a:ea typeface="Segoe UI" pitchFamily="34" charset="-122"/>
                 <a:cs typeface="Segoe UI" pitchFamily="34" charset="-120"/>
               </a:rPr>
-              <a:t>Countries reached</a:t>
+              <a:t>Configured AI models</a:t>
             </a:r>
             <a:endParaRPr lang="en-US" sz="1200" dirty="0"/>
           </a:p>
@@ -4505,7 +4517,7 @@
                 <a:ea typeface="Segoe UI" pitchFamily="34" charset="-122"/>
                 <a:cs typeface="Segoe UI" pitchFamily="34" charset="-120"/>
               </a:rPr>
-              <a:t>432</a:t>
+              <a:t>14</a:t>
             </a:r>
             <a:endParaRPr lang="en-US" sz="3400" dirty="0"/>
           </a:p>
@@ -4544,7 +4556,7 @@
                 <a:ea typeface="Segoe UI" pitchFamily="34" charset="-122"/>
                 <a:cs typeface="Segoe UI" pitchFamily="34" charset="-120"/>
               </a:rPr>
-              <a:t>Sessions</a:t>
+              <a:t>Native pricing regions</a:t>
             </a:r>
             <a:endParaRPr lang="en-US" sz="1200" dirty="0"/>
           </a:p>
@@ -4635,7 +4647,7 @@
                 <a:ea typeface="Segoe UI" pitchFamily="34" charset="-122"/>
                 <a:cs typeface="Segoe UI" pitchFamily="34" charset="-120"/>
               </a:rPr>
-              <a:t>2,873</a:t>
+              <a:t>13</a:t>
             </a:r>
             <a:endParaRPr lang="en-US" sz="3400" dirty="0"/>
           </a:p>
@@ -4674,7 +4686,7 @@
                 <a:ea typeface="Segoe UI" pitchFamily="34" charset="-122"/>
                 <a:cs typeface="Segoe UI" pitchFamily="34" charset="-120"/>
               </a:rPr>
-              <a:t>Tracked events</a:t>
+              <a:t>Deterministic MCP tools</a:t>
             </a:r>
             <a:endParaRPr lang="en-US" sz="1200" dirty="0"/>
           </a:p>
@@ -4765,7 +4777,7 @@
                 <a:ea typeface="Segoe UI" pitchFamily="34" charset="-122"/>
                 <a:cs typeface="Segoe UI" pitchFamily="34" charset="-120"/>
               </a:rPr>
-              <a:t>151</a:t>
+              <a:t>Chat</a:t>
             </a:r>
             <a:endParaRPr lang="en-US" sz="3400" dirty="0"/>
           </a:p>
@@ -4804,7 +4816,7 @@
                 <a:ea typeface="Segoe UI" pitchFamily="34" charset="-122"/>
                 <a:cs typeface="Segoe UI" pitchFamily="34" charset="-120"/>
               </a:rPr>
-              <a:t>Cities reached</a:t>
+              <a:t>Conversational refinement</a:t>
             </a:r>
             <a:endParaRPr lang="en-US" sz="1200" dirty="0"/>
           </a:p>
@@ -4895,7 +4907,7 @@
                 <a:ea typeface="Segoe UI" pitchFamily="34" charset="-122"/>
                 <a:cs typeface="Segoe UI" pitchFamily="34" charset="-120"/>
               </a:rPr>
-              <a:t>~$109</a:t>
+              <a:t>Blueprint</a:t>
             </a:r>
             <a:endParaRPr lang="en-US" sz="3400" dirty="0"/>
           </a:p>
@@ -4934,7 +4946,7 @@
                 <a:ea typeface="Segoe UI" pitchFamily="34" charset="-122"/>
                 <a:cs typeface="Segoe UI" pitchFamily="34" charset="-120"/>
               </a:rPr>
-              <a:t>LLM cost / month</a:t>
+              <a:t>Presentation-ready output</a:t>
             </a:r>
             <a:endParaRPr lang="en-US" sz="1200" dirty="0"/>
           </a:p>
@@ -5025,7 +5037,7 @@
                 <a:ea typeface="Segoe UI" pitchFamily="34" charset="-122"/>
                 <a:cs typeface="Segoe UI" pitchFamily="34" charset="-120"/>
               </a:rPr>
-              <a:t>~$0.41</a:t>
+              <a:t>Autosave</a:t>
             </a:r>
             <a:endParaRPr lang="en-US" sz="3400" dirty="0"/>
           </a:p>
@@ -5064,7 +5076,7 @@
                 <a:ea typeface="Segoe UI" pitchFamily="34" charset="-122"/>
                 <a:cs typeface="Segoe UI" pitchFamily="34" charset="-120"/>
               </a:rPr>
-              <a:t>Cost per user / mo</a:t>
+              <a:t>Recovery built into the canvas</a:t>
             </a:r>
             <a:endParaRPr lang="en-US" sz="1200" dirty="0"/>
           </a:p>
@@ -5155,7 +5167,7 @@
                 <a:ea typeface="Segoe UI" pitchFamily="34" charset="-122"/>
                 <a:cs typeface="Segoe UI" pitchFamily="34" charset="-120"/>
               </a:rPr>
-              <a:t>520</a:t>
+              <a:t>azd</a:t>
             </a:r>
             <a:endParaRPr lang="en-US" sz="3400" dirty="0"/>
           </a:p>
@@ -5194,7 +5206,7 @@
                 <a:ea typeface="Segoe UI" pitchFamily="34" charset="-122"/>
                 <a:cs typeface="Segoe UI" pitchFamily="34" charset="-120"/>
               </a:rPr>
-              <a:t>Architectures generated</a:t>
+              <a:t>Greenfield self-deployment</a:t>
             </a:r>
             <a:endParaRPr lang="en-US" sz="1200" dirty="0"/>
           </a:p>
@@ -5233,7 +5245,7 @@
                 <a:ea typeface="Segoe UI" pitchFamily="34" charset="-122"/>
                 <a:cs typeface="Segoe UI" pitchFamily="34" charset="-120"/>
               </a:rPr>
-              <a:t>Globally adopted, maintained by one person on a personal subscription — </a:t>
+              <a:t>Two interfaces, one design system: </a:t>
             </a:r>
             <a:pPr algn="ctr" indent="0" marL="0">
               <a:buNone/>
@@ -5247,7 +5259,7 @@
                 <a:ea typeface="Segoe UI" pitchFamily="34" charset="-122"/>
                 <a:cs typeface="Segoe UI" pitchFamily="34" charset="-120"/>
               </a:rPr>
-              <a:t>for the price of two coffees a month.</a:t>
+              <a:t>an interactive web app for people and deterministic MCP tools for agents.</a:t>
             </a:r>
             <a:endParaRPr lang="en-US" sz="1500" dirty="0"/>
           </a:p>
@@ -5278,7 +5290,7 @@
               <a:buNone/>
             </a:pPr>
             <a:r>
-              <a:rPr lang="en-US" sz="900" dirty="0">
+              <a:rPr lang="en-US" sz="1000" dirty="0">
                 <a:solidFill>
                   <a:srgbClr val="5B6B82"/>
                 </a:solidFill>
@@ -5288,7 +5300,7 @@
               </a:rPr>
               <a:t>Azure Architecture Diagram Builder</a:t>
             </a:r>
-            <a:endParaRPr lang="en-US" sz="900" dirty="0"/>
+            <a:endParaRPr lang="en-US" sz="1000" dirty="0"/>
           </a:p>
         </p:txBody>
       </p:sp>
@@ -5317,7 +5329,7 @@
               <a:buNone/>
             </a:pPr>
             <a:r>
-              <a:rPr lang="en-US" sz="900" dirty="0">
+              <a:rPr lang="en-US" sz="1000" dirty="0">
                 <a:solidFill>
                   <a:srgbClr val="5B6B82"/>
                 </a:solidFill>
@@ -5327,7 +5339,7 @@
               </a:rPr>
               <a:t>3</a:t>
             </a:r>
-            <a:endParaRPr lang="en-US" sz="900" dirty="0"/>
+            <a:endParaRPr lang="en-US" sz="1000" dirty="0"/>
           </a:p>
         </p:txBody>
       </p:sp>
@@ -5416,7 +5428,7 @@
                 <a:ea typeface="Segoe UI" pitchFamily="34" charset="-122"/>
                 <a:cs typeface="Segoe UI" pitchFamily="34" charset="-120"/>
               </a:rPr>
-              <a:t>GROWTH</a:t>
+              <a:t>RECENT USE</a:t>
             </a:r>
             <a:endParaRPr lang="en-US" sz="1200" dirty="0"/>
           </a:p>
@@ -5455,7 +5467,7 @@
                 <a:ea typeface="Segoe UI" pitchFamily="34" charset="-122"/>
                 <a:cs typeface="Segoe UI" pitchFamily="34" charset="-120"/>
               </a:rPr>
-              <a:t>Adoption is accelerating — organically</a:t>
+              <a:t>People move beyond generation to validation and delivery</a:t>
             </a:r>
             <a:endParaRPr lang="en-US" sz="2800" dirty="0"/>
           </a:p>
@@ -5557,7 +5569,7 @@
                 <a:ea typeface="Segoe UI" pitchFamily="34" charset="-122"/>
                 <a:cs typeface="Segoe UI" pitchFamily="34" charset="-120"/>
               </a:rPr>
-              <a:t>STILL CLIMBING</a:t>
+              <a:t>30 COMPLETE DAYS</a:t>
             </a:r>
             <a:endParaRPr lang="en-US" sz="1200" dirty="0"/>
           </a:p>
@@ -5596,7 +5608,7 @@
                 <a:ea typeface="Segoe UI" pitchFamily="34" charset="-122"/>
                 <a:cs typeface="Segoe UI" pitchFamily="34" charset="-120"/>
               </a:rPr>
-              <a:t>155</a:t>
+              <a:t>470</a:t>
             </a:r>
             <a:endParaRPr lang="en-US" sz="5600" dirty="0"/>
           </a:p>
@@ -5635,7 +5647,7 @@
                 <a:ea typeface="Segoe UI" pitchFamily="34" charset="-122"/>
                 <a:cs typeface="Segoe UI" pitchFamily="34" charset="-120"/>
               </a:rPr>
-              <a:t>active users in June (22 days) — up from 10 in April. May’s 10× jump was no fluke.</a:t>
+              <a:t>feature users across 47 countries, measured from browser telemetry.</a:t>
             </a:r>
             <a:endParaRPr lang="en-US" sz="1400" dirty="0"/>
           </a:p>
@@ -5677,7 +5689,7 @@
                 <a:ea typeface="Segoe UI" pitchFamily="34" charset="-122"/>
                 <a:cs typeface="Segoe UI" pitchFamily="34" charset="-120"/>
               </a:rPr>
-              <a:t>Recent months
+              <a:t>Window
 </a:t>
             </a:r>
             <a:endParaRPr lang="en-US" sz="1300" dirty="0"/>
@@ -5698,7 +5710,7 @@
                 <a:ea typeface="Segoe UI" pitchFamily="34" charset="-122"/>
                 <a:cs typeface="Segoe UI" pitchFamily="34" charset="-120"/>
               </a:rPr>
-              <a:t>Jun — 155 users / 1,151 events</a:t>
+              <a:t>2026-08-22 through 2026-09-20</a:t>
             </a:r>
             <a:endParaRPr lang="en-US" sz="1300" dirty="0"/>
           </a:p>
@@ -5718,7 +5730,7 @@
                 <a:ea typeface="Segoe UI" pitchFamily="34" charset="-122"/>
                 <a:cs typeface="Segoe UI" pitchFamily="34" charset="-120"/>
               </a:rPr>
-              <a:t>May — 109 users / 1,370 events</a:t>
+              <a:t>772 sessions · 8,834 feature events</a:t>
             </a:r>
             <a:endParaRPr lang="en-US" sz="1300" dirty="0"/>
           </a:p>
@@ -5749,7 +5761,7 @@
               <a:buNone/>
             </a:pPr>
             <a:r>
-              <a:rPr lang="en-US" sz="900" dirty="0">
+              <a:rPr lang="en-US" sz="1000" dirty="0">
                 <a:solidFill>
                   <a:srgbClr val="5B6B82"/>
                 </a:solidFill>
@@ -5759,7 +5771,7 @@
               </a:rPr>
               <a:t>Azure Architecture Diagram Builder</a:t>
             </a:r>
-            <a:endParaRPr lang="en-US" sz="900" dirty="0"/>
+            <a:endParaRPr lang="en-US" sz="1000" dirty="0"/>
           </a:p>
         </p:txBody>
       </p:sp>
@@ -5788,7 +5800,7 @@
               <a:buNone/>
             </a:pPr>
             <a:r>
-              <a:rPr lang="en-US" sz="900" dirty="0">
+              <a:rPr lang="en-US" sz="1000" dirty="0">
                 <a:solidFill>
                   <a:srgbClr val="5B6B82"/>
                 </a:solidFill>
@@ -5798,7 +5810,7 @@
               </a:rPr>
               <a:t>4</a:t>
             </a:r>
-            <a:endParaRPr lang="en-US" sz="900" dirty="0"/>
+            <a:endParaRPr lang="en-US" sz="1000" dirty="0"/>
           </a:p>
         </p:txBody>
       </p:sp>
@@ -6017,7 +6029,7 @@
                 <a:ea typeface="Segoe UI" pitchFamily="34" charset="-122"/>
                 <a:cs typeface="Segoe UI" pitchFamily="34" charset="-120"/>
               </a:rPr>
-              <a:t>AI</a:t>
+              <a:t>IN</a:t>
             </a:r>
             <a:endParaRPr lang="en-US" sz="2200" dirty="0"/>
           </a:p>
@@ -6056,7 +6068,7 @@
                 <a:ea typeface="Segoe UI" pitchFamily="34" charset="-122"/>
                 <a:cs typeface="Segoe UI" pitchFamily="34" charset="-120"/>
               </a:rPr>
-              <a:t>AI generation</a:t>
+              <a:t>Flexible intake</a:t>
             </a:r>
             <a:endParaRPr lang="en-US" sz="1450" dirty="0"/>
           </a:p>
@@ -6095,7 +6107,7 @@
                 <a:ea typeface="Segoe UI" pitchFamily="34" charset="-122"/>
                 <a:cs typeface="Segoe UI" pitchFamily="34" charset="-120"/>
               </a:rPr>
-              <a:t>Natural-language prompts become laid-out diagrams across 12+ frontier models.</a:t>
+              <a:t>Start from natural language, an image, templates, or live Azure resources.</a:t>
             </a:r>
             <a:endParaRPr lang="en-US" sz="1100" dirty="0"/>
           </a:p>
@@ -6186,7 +6198,7 @@
                 <a:ea typeface="Segoe UI" pitchFamily="34" charset="-122"/>
                 <a:cs typeface="Segoe UI" pitchFamily="34" charset="-120"/>
               </a:rPr>
-              <a:t>WAF</a:t>
+              <a:t>AI</a:t>
             </a:r>
             <a:endParaRPr lang="en-US" sz="2200" dirty="0"/>
           </a:p>
@@ -6225,7 +6237,7 @@
                 <a:ea typeface="Segoe UI" pitchFamily="34" charset="-122"/>
                 <a:cs typeface="Segoe UI" pitchFamily="34" charset="-120"/>
               </a:rPr>
-              <a:t>WAF validation</a:t>
+              <a:t>Generate + refine</a:t>
             </a:r>
             <a:endParaRPr lang="en-US" sz="1450" dirty="0"/>
           </a:p>
@@ -6264,7 +6276,7 @@
                 <a:ea typeface="Segoe UI" pitchFamily="34" charset="-122"/>
                 <a:cs typeface="Segoe UI" pitchFamily="34" charset="-120"/>
               </a:rPr>
-              <a:t>Scored Well-Architected reviews surface concrete reliability, security &amp; cost gaps.</a:t>
+              <a:t>Choose among 15 models, then use Guided Chat without erasing deliberate canvas work.</a:t>
             </a:r>
             <a:endParaRPr lang="en-US" sz="1100" dirty="0"/>
           </a:p>
@@ -6355,7 +6367,7 @@
                 <a:ea typeface="Segoe UI" pitchFamily="34" charset="-122"/>
                 <a:cs typeface="Segoe UI" pitchFamily="34" charset="-120"/>
               </a:rPr>
-              <a:t>$</a:t>
+              <a:t>BP</a:t>
             </a:r>
             <a:endParaRPr lang="en-US" sz="2200" dirty="0"/>
           </a:p>
@@ -6394,7 +6406,7 @@
                 <a:ea typeface="Segoe UI" pitchFamily="34" charset="-122"/>
                 <a:cs typeface="Segoe UI" pitchFamily="34" charset="-120"/>
               </a:rPr>
-              <a:t>Multi-region cost</a:t>
+              <a:t>Topology + Blueprint</a:t>
             </a:r>
             <a:endParaRPr lang="en-US" sz="1450" dirty="0"/>
           </a:p>
@@ -6433,7 +6445,7 @@
                 <a:ea typeface="Segoe UI" pitchFamily="34" charset="-122"/>
                 <a:cs typeface="Segoe UI" pitchFamily="34" charset="-120"/>
               </a:rPr>
-              <a:t>Live estimates across 8 Azure regions with ranked comparison and savings flags.</a:t>
+              <a:t>Create an editable engineering view and a polished presentation view from one brief.</a:t>
             </a:r>
             <a:endParaRPr lang="en-US" sz="1100" dirty="0"/>
           </a:p>
@@ -6524,7 +6536,7 @@
                 <a:ea typeface="Segoe UI" pitchFamily="34" charset="-122"/>
                 <a:cs typeface="Segoe UI" pitchFamily="34" charset="-120"/>
               </a:rPr>
-              <a:t>IaC</a:t>
+              <a:t>WAF</a:t>
             </a:r>
             <a:endParaRPr lang="en-US" sz="2200" dirty="0"/>
           </a:p>
@@ -6563,7 +6575,7 @@
                 <a:ea typeface="Segoe UI" pitchFamily="34" charset="-122"/>
                 <a:cs typeface="Segoe UI" pitchFamily="34" charset="-120"/>
               </a:rPr>
-              <a:t>Deployment guides</a:t>
+              <a:t>Evidence-aware review</a:t>
             </a:r>
             <a:endParaRPr lang="en-US" sz="1450" dirty="0"/>
           </a:p>
@@ -6602,7 +6614,7 @@
                 <a:ea typeface="Segoe UI" pitchFamily="34" charset="-122"/>
                 <a:cs typeface="Segoe UI" pitchFamily="34" charset="-120"/>
               </a:rPr>
-              <a:t>Generates Bicep templates, prerequisites, and verification steps per service.</a:t>
+              <a:t>Score diagram-level WAF gaps, apply recommendations, and compare model critiques.</a:t>
             </a:r>
             <a:endParaRPr lang="en-US" sz="1100" dirty="0"/>
           </a:p>
@@ -6693,7 +6705,7 @@
                 <a:ea typeface="Segoe UI" pitchFamily="34" charset="-122"/>
                 <a:cs typeface="Segoe UI" pitchFamily="34" charset="-120"/>
               </a:rPr>
-              <a:t>⇄</a:t>
+              <a:t>$</a:t>
             </a:r>
             <a:endParaRPr lang="en-US" sz="2200" dirty="0"/>
           </a:p>
@@ -6732,7 +6744,7 @@
                 <a:ea typeface="Segoe UI" pitchFamily="34" charset="-122"/>
                 <a:cs typeface="Segoe UI" pitchFamily="34" charset="-120"/>
               </a:rPr>
-              <a:t>Workflow &amp; narration</a:t>
+              <a:t>Cost with provenance</a:t>
             </a:r>
             <a:endParaRPr lang="en-US" sz="1450" dirty="0"/>
           </a:p>
@@ -6771,7 +6783,7 @@
                 <a:ea typeface="Segoe UI" pitchFamily="34" charset="-122"/>
                 <a:cs typeface="Segoe UI" pitchFamily="34" charset="-120"/>
               </a:rPr>
-              <a:t>Animated step-by-step data-flow walkthroughs with optional avatar narration.</a:t>
+              <a:t>Compare native prices across 14 regions with explicit coverage and pricing dates.</a:t>
             </a:r>
             <a:endParaRPr lang="en-US" sz="1100" dirty="0"/>
           </a:p>
@@ -6862,7 +6874,7 @@
                 <a:ea typeface="Segoe UI" pitchFamily="34" charset="-122"/>
                 <a:cs typeface="Segoe UI" pitchFamily="34" charset="-120"/>
               </a:rPr>
-              <a:t>↧</a:t>
+              <a:t>OUT</a:t>
             </a:r>
             <a:endParaRPr lang="en-US" sz="2200" dirty="0"/>
           </a:p>
@@ -6901,7 +6913,7 @@
                 <a:ea typeface="Segoe UI" pitchFamily="34" charset="-122"/>
                 <a:cs typeface="Segoe UI" pitchFamily="34" charset="-120"/>
               </a:rPr>
-              <a:t>8 export formats</a:t>
+              <a:t>Deliver and extend</a:t>
             </a:r>
             <a:endParaRPr lang="en-US" sz="1450" dirty="0"/>
           </a:p>
@@ -6940,7 +6952,7 @@
                 <a:ea typeface="Segoe UI" pitchFamily="34" charset="-122"/>
                 <a:cs typeface="Segoe UI" pitchFamily="34" charset="-120"/>
               </a:rPr>
-              <a:t>PNG, SVG, PPTX, Draw.io, HTML, JSON, CSV, and az-prototype IaC round-trips.</a:t>
+              <a:t>Export diagrams, reports, IaC guides, or call deterministic design tools through MCP.</a:t>
             </a:r>
             <a:endParaRPr lang="en-US" sz="1100" dirty="0"/>
           </a:p>
@@ -6971,7 +6983,7 @@
               <a:buNone/>
             </a:pPr>
             <a:r>
-              <a:rPr lang="en-US" sz="900" dirty="0">
+              <a:rPr lang="en-US" sz="1000" dirty="0">
                 <a:solidFill>
                   <a:srgbClr val="5B6B82"/>
                 </a:solidFill>
@@ -6981,7 +6993,7 @@
               </a:rPr>
               <a:t>Azure Architecture Diagram Builder</a:t>
             </a:r>
-            <a:endParaRPr lang="en-US" sz="900" dirty="0"/>
+            <a:endParaRPr lang="en-US" sz="1000" dirty="0"/>
           </a:p>
         </p:txBody>
       </p:sp>
@@ -7010,7 +7022,7 @@
               <a:buNone/>
             </a:pPr>
             <a:r>
-              <a:rPr lang="en-US" sz="900" dirty="0">
+              <a:rPr lang="en-US" sz="1000" dirty="0">
                 <a:solidFill>
                   <a:srgbClr val="5B6B82"/>
                 </a:solidFill>
@@ -7020,7 +7032,7 @@
               </a:rPr>
               <a:t>5</a:t>
             </a:r>
-            <a:endParaRPr lang="en-US" sz="900" dirty="0"/>
+            <a:endParaRPr lang="en-US" sz="1000" dirty="0"/>
           </a:p>
         </p:txBody>
       </p:sp>
@@ -7109,7 +7121,7 @@
                 <a:ea typeface="Segoe UI" pitchFamily="34" charset="-122"/>
                 <a:cs typeface="Segoe UI" pitchFamily="34" charset="-120"/>
               </a:rPr>
-              <a:t>OUTPUT</a:t>
+              <a:t>DELIVERY</a:t>
             </a:r>
             <a:endParaRPr lang="en-US" sz="1200" dirty="0"/>
           </a:p>
@@ -7148,7 +7160,7 @@
                 <a:ea typeface="Segoe UI" pitchFamily="34" charset="-122"/>
                 <a:cs typeface="Segoe UI" pitchFamily="34" charset="-120"/>
               </a:rPr>
-              <a:t>People ship real artifacts, not just pictures</a:t>
+              <a:t>The output leaves the canvas</a:t>
             </a:r>
             <a:endParaRPr lang="en-US" sz="2800" dirty="0"/>
           </a:p>
@@ -7255,7 +7267,7 @@
                 <a:ea typeface="Segoe UI" pitchFamily="34" charset="-122"/>
                 <a:cs typeface="Segoe UI" pitchFamily="34" charset="-120"/>
               </a:rPr>
-              <a:t>376</a:t>
+              <a:t>832</a:t>
             </a:r>
             <a:endParaRPr lang="en-US" sz="3000" dirty="0"/>
           </a:p>
@@ -7294,7 +7306,7 @@
                 <a:ea typeface="Segoe UI" pitchFamily="34" charset="-122"/>
                 <a:cs typeface="Segoe UI" pitchFamily="34" charset="-120"/>
               </a:rPr>
-              <a:t>diagrams exported by 83 users</a:t>
+              <a:t>total exports by 147 users</a:t>
             </a:r>
             <a:endParaRPr lang="en-US" sz="1250" dirty="0"/>
           </a:p>
@@ -7385,7 +7397,7 @@
                 <a:ea typeface="Segoe UI" pitchFamily="34" charset="-122"/>
                 <a:cs typeface="Segoe UI" pitchFamily="34" charset="-120"/>
               </a:rPr>
-              <a:t>50</a:t>
+              <a:t>40</a:t>
             </a:r>
             <a:endParaRPr lang="en-US" sz="3000" dirty="0"/>
           </a:p>
@@ -7424,7 +7436,7 @@
                 <a:ea typeface="Segoe UI" pitchFamily="34" charset="-122"/>
                 <a:cs typeface="Segoe UI" pitchFamily="34" charset="-120"/>
               </a:rPr>
-              <a:t>Bicep deployment guides generated</a:t>
+              <a:t>deployment guides by 32 users</a:t>
             </a:r>
             <a:endParaRPr lang="en-US" sz="1250" dirty="0"/>
           </a:p>
@@ -7515,7 +7527,7 @@
                 <a:ea typeface="Segoe UI" pitchFamily="34" charset="-122"/>
                 <a:cs typeface="Segoe UI" pitchFamily="34" charset="-120"/>
               </a:rPr>
-              <a:t>19</a:t>
+              <a:t>41</a:t>
             </a:r>
             <a:endParaRPr lang="en-US" sz="3000" dirty="0"/>
           </a:p>
@@ -7554,7 +7566,7 @@
                 <a:ea typeface="Segoe UI" pitchFamily="34" charset="-122"/>
                 <a:cs typeface="Segoe UI" pitchFamily="34" charset="-120"/>
               </a:rPr>
-              <a:t>IaC imports — ARM 9 · Bicep 6 · Terraform 4</a:t>
+              <a:t>IaC imports by 21 users</a:t>
             </a:r>
             <a:endParaRPr lang="en-US" sz="1250" dirty="0"/>
           </a:p>
@@ -7585,7 +7597,7 @@
               <a:buNone/>
             </a:pPr>
             <a:r>
-              <a:rPr lang="en-US" sz="900" dirty="0">
+              <a:rPr lang="en-US" sz="1000" dirty="0">
                 <a:solidFill>
                   <a:srgbClr val="5B6B82"/>
                 </a:solidFill>
@@ -7595,7 +7607,7 @@
               </a:rPr>
               <a:t>Azure Architecture Diagram Builder</a:t>
             </a:r>
-            <a:endParaRPr lang="en-US" sz="900" dirty="0"/>
+            <a:endParaRPr lang="en-US" sz="1000" dirty="0"/>
           </a:p>
         </p:txBody>
       </p:sp>
@@ -7624,7 +7636,7 @@
               <a:buNone/>
             </a:pPr>
             <a:r>
-              <a:rPr lang="en-US" sz="900" dirty="0">
+              <a:rPr lang="en-US" sz="1000" dirty="0">
                 <a:solidFill>
                   <a:srgbClr val="5B6B82"/>
                 </a:solidFill>
@@ -7634,7 +7646,7 @@
               </a:rPr>
               <a:t>6</a:t>
             </a:r>
-            <a:endParaRPr lang="en-US" sz="900" dirty="0"/>
+            <a:endParaRPr lang="en-US" sz="1000" dirty="0"/>
           </a:p>
         </p:txBody>
       </p:sp>
@@ -7723,7 +7735,7 @@
                 <a:ea typeface="Segoe UI" pitchFamily="34" charset="-122"/>
                 <a:cs typeface="Segoe UI" pitchFamily="34" charset="-120"/>
               </a:rPr>
-              <a:t>CHOICE</a:t>
+              <a:t>MODEL LAYER</a:t>
             </a:r>
             <a:endParaRPr lang="en-US" sz="1200" dirty="0"/>
           </a:p>
@@ -7762,7 +7774,7 @@
                 <a:ea typeface="Segoe UI" pitchFamily="34" charset="-122"/>
                 <a:cs typeface="Segoe UI" pitchFamily="34" charset="-120"/>
               </a:rPr>
-              <a:t>Multi-model by design</a:t>
+              <a:t>Multi-model by design, measured at the server</a:t>
             </a:r>
             <a:endParaRPr lang="en-US" sz="2800" dirty="0"/>
           </a:p>
@@ -7801,7 +7813,7 @@
                 <a:ea typeface="Segoe UI" pitchFamily="34" charset="-122"/>
                 <a:cs typeface="Segoe UI" pitchFamily="34" charset="-120"/>
               </a:rPr>
-              <a:t>12+ frontier models in production — users compare quality, latency, and cost side by side.</a:t>
+              <a:t>15 configured models across GPT-5.x, MAI, DeepSeek, Grok, Mistral, and Kimi.</a:t>
             </a:r>
             <a:endParaRPr lang="en-US" sz="1300" dirty="0"/>
           </a:p>
@@ -7903,7 +7915,7 @@
                 <a:ea typeface="Segoe UI" pitchFamily="34" charset="-122"/>
                 <a:cs typeface="Segoe UI" pitchFamily="34" charset="-120"/>
               </a:rPr>
-              <a:t>WAF VALIDATION</a:t>
+              <a:t>AUTHORITATIVE TRAFFIC</a:t>
             </a:r>
             <a:endParaRPr lang="en-US" sz="1200" dirty="0"/>
           </a:p>
@@ -7942,7 +7954,7 @@
                 <a:ea typeface="Segoe UI" pitchFamily="34" charset="-122"/>
                 <a:cs typeface="Segoe UI" pitchFamily="34" charset="-120"/>
               </a:rPr>
-              <a:t>146 runs</a:t>
+              <a:t>2,880 calls</a:t>
             </a:r>
             <a:endParaRPr lang="en-US" sz="3400" dirty="0"/>
           </a:p>
@@ -7981,7 +7993,7 @@
                 <a:ea typeface="Segoe UI" pitchFamily="34" charset="-122"/>
                 <a:cs typeface="Segoe UI" pitchFamily="34" charset="-120"/>
               </a:rPr>
-              <a:t>Structured, scored design feedback — average 62–71 / 100 across leading models, surfacing concrete gaps before deployment.</a:t>
+              <a:t>14.5M tokens processed. 2,855 requests succeeded; 25 failed; 2 were throttled.</a:t>
             </a:r>
             <a:endParaRPr lang="en-US" sz="1350" dirty="0"/>
           </a:p>
@@ -8020,7 +8032,7 @@
                 <a:ea typeface="Segoe UI" pitchFamily="34" charset="-122"/>
                 <a:cs typeface="Segoe UI" pitchFamily="34" charset="-120"/>
               </a:rPr>
-              <a:t>Also exercised: </a:t>
+              <a:t>Scope: </a:t>
             </a:r>
             <a:pPr indent="0" marL="0">
               <a:buNone/>
@@ -8034,7 +8046,7 @@
                 <a:ea typeface="Segoe UI" pitchFamily="34" charset="-122"/>
                 <a:cs typeface="Segoe UI" pitchFamily="34" charset="-120"/>
               </a:rPr>
-              <a:t>DeepSeek, Kimi, Mistral, GPT-OSS, and more.</a:t>
+              <a:t>production web app model proxy. Window: 22 Aug–20 Sep 2026.</a:t>
             </a:r>
             <a:endParaRPr lang="en-US" sz="1300" dirty="0"/>
           </a:p>
@@ -8065,7 +8077,7 @@
               <a:buNone/>
             </a:pPr>
             <a:r>
-              <a:rPr lang="en-US" sz="900" dirty="0">
+              <a:rPr lang="en-US" sz="1000" dirty="0">
                 <a:solidFill>
                   <a:srgbClr val="5B6B82"/>
                 </a:solidFill>
@@ -8075,7 +8087,7 @@
               </a:rPr>
               <a:t>Azure Architecture Diagram Builder</a:t>
             </a:r>
-            <a:endParaRPr lang="en-US" sz="900" dirty="0"/>
+            <a:endParaRPr lang="en-US" sz="1000" dirty="0"/>
           </a:p>
         </p:txBody>
       </p:sp>
@@ -8104,7 +8116,7 @@
               <a:buNone/>
             </a:pPr>
             <a:r>
-              <a:rPr lang="en-US" sz="900" dirty="0">
+              <a:rPr lang="en-US" sz="1000" dirty="0">
                 <a:solidFill>
                   <a:srgbClr val="5B6B82"/>
                 </a:solidFill>
@@ -8114,7 +8126,7 @@
               </a:rPr>
               <a:t>7</a:t>
             </a:r>
-            <a:endParaRPr lang="en-US" sz="900" dirty="0"/>
+            <a:endParaRPr lang="en-US" sz="1000" dirty="0"/>
           </a:p>
         </p:txBody>
       </p:sp>
@@ -8203,7 +8215,7 @@
                 <a:ea typeface="Segoe UI" pitchFamily="34" charset="-122"/>
                 <a:cs typeface="Segoe UI" pitchFamily="34" charset="-120"/>
               </a:rPr>
-              <a:t>ECONOMICS</a:t>
+              <a:t>OPERATIONS</a:t>
             </a:r>
             <a:endParaRPr lang="en-US" sz="1200" dirty="0"/>
           </a:p>
@@ -8242,7 +8254,7 @@
                 <a:ea typeface="Segoe UI" pitchFamily="34" charset="-122"/>
                 <a:cs typeface="Segoe UI" pitchFamily="34" charset="-120"/>
               </a:rPr>
-              <a:t>Enterprise-grade guidance at hobby-grade cost</a:t>
+              <a:t>Instrumented for responsible experimentation</a:t>
             </a:r>
             <a:endParaRPr lang="en-US" sz="2800" dirty="0"/>
           </a:p>
@@ -8295,7 +8307,7 @@
             <a:avLst/>
           </a:prstGeom>
           <a:solidFill>
-            <a:srgbClr val="F2A900"/>
+            <a:srgbClr val="3FB950"/>
           </a:solidFill>
           <a:ln/>
         </p:spPr>
@@ -8333,7 +8345,7 @@
                 <a:ea typeface="Segoe UI" pitchFamily="34" charset="-122"/>
                 <a:cs typeface="Segoe UI" pitchFamily="34" charset="-120"/>
               </a:rPr>
-              <a:t>$108.52</a:t>
+              <a:t>99.1%</a:t>
             </a:r>
             <a:endParaRPr lang="en-US" sz="3400" dirty="0"/>
           </a:p>
@@ -8372,7 +8384,7 @@
                 <a:ea typeface="Segoe UI" pitchFamily="34" charset="-122"/>
                 <a:cs typeface="Segoe UI" pitchFamily="34" charset="-120"/>
               </a:rPr>
-              <a:t>attributable token spend / 30 days</a:t>
+              <a:t>server model request success</a:t>
             </a:r>
             <a:endParaRPr lang="en-US" sz="1250" dirty="0"/>
           </a:p>
@@ -8463,7 +8475,7 @@
                 <a:ea typeface="Segoe UI" pitchFamily="34" charset="-122"/>
                 <a:cs typeface="Segoe UI" pitchFamily="34" charset="-120"/>
               </a:rPr>
-              <a:t>$17.88</a:t>
+              <a:t>423</a:t>
             </a:r>
             <a:endParaRPr lang="en-US" sz="3400" dirty="0"/>
           </a:p>
@@ -8502,7 +8514,7 @@
                 <a:ea typeface="Segoe UI" pitchFamily="34" charset="-122"/>
                 <a:cs typeface="Segoe UI" pitchFamily="34" charset="-120"/>
               </a:rPr>
-              <a:t>blended cost per 1M tokens</a:t>
+              <a:t>rotating client signals</a:t>
             </a:r>
             <a:endParaRPr lang="en-US" sz="1250" dirty="0"/>
           </a:p>
@@ -8593,7 +8605,7 @@
                 <a:ea typeface="Segoe UI" pitchFamily="34" charset="-122"/>
                 <a:cs typeface="Segoe UI" pitchFamily="34" charset="-120"/>
               </a:rPr>
-              <a:t>$0.12</a:t>
+              <a:t>v2.0.4</a:t>
             </a:r>
             <a:endParaRPr lang="en-US" sz="3400" dirty="0"/>
           </a:p>
@@ -8632,7 +8644,7 @@
                 <a:ea typeface="Segoe UI" pitchFamily="34" charset="-122"/>
                 <a:cs typeface="Segoe UI" pitchFamily="34" charset="-120"/>
               </a:rPr>
-              <a:t>avg cost per generation call</a:t>
+              <a:t>active production revision</a:t>
             </a:r>
             <a:endParaRPr lang="en-US" sz="1250" dirty="0"/>
           </a:p>
@@ -8685,7 +8697,7 @@
             <a:avLst/>
           </a:prstGeom>
           <a:solidFill>
-            <a:srgbClr val="3FB950"/>
+            <a:srgbClr val="F2A900"/>
           </a:solidFill>
           <a:ln/>
         </p:spPr>
@@ -8723,7 +8735,7 @@
                 <a:ea typeface="Segoe UI" pitchFamily="34" charset="-122"/>
                 <a:cs typeface="Segoe UI" pitchFamily="34" charset="-120"/>
               </a:rPr>
-              <a:t>~$0.41</a:t>
+              <a:t>200</a:t>
             </a:r>
             <a:endParaRPr lang="en-US" sz="3400" dirty="0"/>
           </a:p>
@@ -8762,7 +8774,7 @@
                 <a:ea typeface="Segoe UI" pitchFamily="34" charset="-122"/>
                 <a:cs typeface="Segoe UI" pitchFamily="34" charset="-120"/>
               </a:rPr>
-              <a:t>cost per active user / month</a:t>
+              <a:t>MCP discovery response</a:t>
             </a:r>
             <a:endParaRPr lang="en-US" sz="1250" dirty="0"/>
           </a:p>
@@ -8829,7 +8841,7 @@
                 <a:ea typeface="Segoe UI" pitchFamily="34" charset="-122"/>
                 <a:cs typeface="Segoe UI" pitchFamily="34" charset="-120"/>
               </a:rPr>
-              <a:t>Validated, multi-cloud-quality Azure architecture guidance delivered to </a:t>
+              <a:t>Browser telemetry measures product use. Server logs measure model traffic. </a:t>
             </a:r>
             <a:pPr algn="ctr" indent="0" marL="0">
               <a:lnSpc>
@@ -8846,24 +8858,7 @@
                 <a:ea typeface="Segoe UI" pitchFamily="34" charset="-122"/>
                 <a:cs typeface="Segoe UI" pitchFamily="34" charset="-120"/>
               </a:rPr>
-              <a:t>267 users across 39 countries</a:t>
-            </a:r>
-            <a:pPr algn="ctr" indent="0" marL="0">
-              <a:lnSpc>
-                <a:spcPct val="115000"/>
-              </a:lnSpc>
-              <a:buNone/>
-            </a:pPr>
-            <a:r>
-              <a:rPr lang="en-US" sz="1800" dirty="0">
-                <a:solidFill>
-                  <a:srgbClr val="DCE8F8"/>
-                </a:solidFill>
-                <a:latin typeface="Segoe UI" pitchFamily="34" charset="0"/>
-                <a:ea typeface="Segoe UI" pitchFamily="34" charset="-122"/>
-                <a:cs typeface="Segoe UI" pitchFamily="34" charset="-120"/>
-              </a:rPr>
-              <a:t> — for the price of two coffees a month, on a single personal subscription.</a:t>
+              <a:t>Prompts, model responses, credentials, raw IPs, and user agents are not retained.</a:t>
             </a:r>
             <a:endParaRPr lang="en-US" sz="1800" dirty="0"/>
           </a:p>
@@ -8894,9 +8889,9 @@
               <a:buNone/>
             </a:pPr>
             <a:r>
-              <a:rPr lang="en-US" sz="900" dirty="0">
-                <a:solidFill>
-                  <a:srgbClr val="5E7799"/>
+              <a:rPr lang="en-US" sz="1000" dirty="0">
+                <a:solidFill>
+                  <a:srgbClr val="9BB0CC"/>
                 </a:solidFill>
                 <a:latin typeface="Segoe UI" pitchFamily="34" charset="0"/>
                 <a:ea typeface="Segoe UI" pitchFamily="34" charset="-122"/>
@@ -8904,7 +8899,7 @@
               </a:rPr>
               <a:t>Azure Architecture Diagram Builder</a:t>
             </a:r>
-            <a:endParaRPr lang="en-US" sz="900" dirty="0"/>
+            <a:endParaRPr lang="en-US" sz="1000" dirty="0"/>
           </a:p>
         </p:txBody>
       </p:sp>
@@ -8933,9 +8928,9 @@
               <a:buNone/>
             </a:pPr>
             <a:r>
-              <a:rPr lang="en-US" sz="900" dirty="0">
-                <a:solidFill>
-                  <a:srgbClr val="5E7799"/>
+              <a:rPr lang="en-US" sz="1000" dirty="0">
+                <a:solidFill>
+                  <a:srgbClr val="9BB0CC"/>
                 </a:solidFill>
                 <a:latin typeface="Segoe UI" pitchFamily="34" charset="0"/>
                 <a:ea typeface="Segoe UI" pitchFamily="34" charset="-122"/>
@@ -8943,7 +8938,7 @@
               </a:rPr>
               <a:t>8</a:t>
             </a:r>
-            <a:endParaRPr lang="en-US" sz="900" dirty="0"/>
+            <a:endParaRPr lang="en-US" sz="1000" dirty="0"/>
           </a:p>
         </p:txBody>
       </p:sp>
@@ -9052,7 +9047,7 @@
                 <a:ea typeface="Segoe UI" pitchFamily="34" charset="-122"/>
                 <a:cs typeface="Segoe UI" pitchFamily="34" charset="-120"/>
               </a:rPr>
-              <a:t>THE ASK</a:t>
+              <a:t>SEE IT WORK</a:t>
             </a:r>
             <a:endParaRPr lang="en-US" sz="1300" dirty="0"/>
           </a:p>
@@ -9091,7 +9086,7 @@
                 <a:ea typeface="Segoe UI" pitchFamily="34" charset="-122"/>
                 <a:cs typeface="Segoe UI" pitchFamily="34" charset="-120"/>
               </a:rPr>
-              <a:t>Help it scale responsibly</a:t>
+              <a:t>One architecture, four moves</a:t>
             </a:r>
             <a:endParaRPr lang="en-US" sz="3400" dirty="0"/>
           </a:p>
@@ -9106,7 +9101,7 @@
         <p:spPr>
           <a:xfrm>
             <a:off x="548640" y="2240280"/>
-            <a:ext cx="3630168" cy="2743200"/>
+            <a:ext cx="2615184" cy="2743200"/>
           </a:xfrm>
           <a:prstGeom prst="rect">
             <a:avLst/>
@@ -9138,7 +9133,7 @@
         <p:spPr>
           <a:xfrm>
             <a:off x="548640" y="2240280"/>
-            <a:ext cx="3630168" cy="109728"/>
+            <a:ext cx="2615184" cy="109728"/>
           </a:xfrm>
           <a:prstGeom prst="rect">
             <a:avLst/>
@@ -9158,7 +9153,7 @@
         <p:spPr>
           <a:xfrm>
             <a:off x="777240" y="2514600"/>
-            <a:ext cx="3172968" cy="640080"/>
+            <a:ext cx="2157984" cy="640080"/>
           </a:xfrm>
           <a:prstGeom prst="rect">
             <a:avLst/>
@@ -9197,7 +9192,7 @@
         <p:spPr>
           <a:xfrm>
             <a:off x="777240" y="3154680"/>
-            <a:ext cx="3172968" cy="640080"/>
+            <a:ext cx="2157984" cy="640080"/>
           </a:xfrm>
           <a:prstGeom prst="rect">
             <a:avLst/>
@@ -9221,7 +9216,7 @@
                 <a:ea typeface="Segoe UI" pitchFamily="34" charset="-122"/>
                 <a:cs typeface="Segoe UI" pitchFamily="34" charset="-120"/>
               </a:rPr>
-              <a:t>Sponsorship / landing zone</a:t>
+              <a:t>Create</a:t>
             </a:r>
             <a:endParaRPr lang="en-US" sz="1700" dirty="0"/>
           </a:p>
@@ -9236,7 +9231,7 @@
         <p:spPr>
           <a:xfrm>
             <a:off x="777240" y="3794760"/>
-            <a:ext cx="3172968" cy="1097280"/>
+            <a:ext cx="2157984" cy="1097280"/>
           </a:xfrm>
           <a:prstGeom prst="rect">
             <a:avLst/>
@@ -9260,7 +9255,7 @@
                 <a:ea typeface="Segoe UI" pitchFamily="34" charset="-122"/>
                 <a:cs typeface="Segoe UI" pitchFamily="34" charset="-120"/>
               </a:rPr>
-              <a:t>Move off a personal subscription onto a funded, right-sized Azure environment with proper quotas and isolation.</a:t>
+              <a:t>Describe the workload or import an existing artifact.</a:t>
             </a:r>
             <a:endParaRPr lang="en-US" sz="1250" dirty="0"/>
           </a:p>
@@ -9274,8 +9269,8 @@
         </p:nvSpPr>
         <p:spPr>
           <a:xfrm>
-            <a:off x="4471416" y="2240280"/>
-            <a:ext cx="3630168" cy="2743200"/>
+            <a:off x="3438144" y="2240280"/>
+            <a:ext cx="2615184" cy="2743200"/>
           </a:xfrm>
           <a:prstGeom prst="rect">
             <a:avLst/>
@@ -9306,8 +9301,8 @@
         </p:nvSpPr>
         <p:spPr>
           <a:xfrm>
-            <a:off x="4471416" y="2240280"/>
-            <a:ext cx="3630168" cy="109728"/>
+            <a:off x="3438144" y="2240280"/>
+            <a:ext cx="2615184" cy="109728"/>
           </a:xfrm>
           <a:prstGeom prst="rect">
             <a:avLst/>
@@ -9326,8 +9321,8 @@
         </p:nvSpPr>
         <p:spPr>
           <a:xfrm>
-            <a:off x="4700016" y="2514600"/>
-            <a:ext cx="3172968" cy="640080"/>
+            <a:off x="3666744" y="2514600"/>
+            <a:ext cx="2157984" cy="640080"/>
           </a:xfrm>
           <a:prstGeom prst="rect">
             <a:avLst/>
@@ -9365,8 +9360,8 @@
         </p:nvSpPr>
         <p:spPr>
           <a:xfrm>
-            <a:off x="4700016" y="3154680"/>
-            <a:ext cx="3172968" cy="640080"/>
+            <a:off x="3666744" y="3154680"/>
+            <a:ext cx="2157984" cy="640080"/>
           </a:xfrm>
           <a:prstGeom prst="rect">
             <a:avLst/>
@@ -9390,7 +9385,7 @@
                 <a:ea typeface="Segoe UI" pitchFamily="34" charset="-122"/>
                 <a:cs typeface="Segoe UI" pitchFamily="34" charset="-120"/>
               </a:rPr>
-              <a:t>Co-maintainers</a:t>
+              <a:t>Refine</a:t>
             </a:r>
             <a:endParaRPr lang="en-US" sz="1700" dirty="0"/>
           </a:p>
@@ -9404,8 +9399,8 @@
         </p:nvSpPr>
         <p:spPr>
           <a:xfrm>
-            <a:off x="4700016" y="3794760"/>
-            <a:ext cx="3172968" cy="1097280"/>
+            <a:off x="3666744" y="3794760"/>
+            <a:ext cx="2157984" cy="1097280"/>
           </a:xfrm>
           <a:prstGeom prst="rect">
             <a:avLst/>
@@ -9429,7 +9424,7 @@
                 <a:ea typeface="Segoe UI" pitchFamily="34" charset="-122"/>
                 <a:cs typeface="Segoe UI" pitchFamily="34" charset="-120"/>
               </a:rPr>
-              <a:t>Reduce the bus-factor of one and accelerate the roadmap with additional contributors.</a:t>
+              <a:t>Add one requirement through Guided Chat.</a:t>
             </a:r>
             <a:endParaRPr lang="en-US" sz="1250" dirty="0"/>
           </a:p>
@@ -9443,8 +9438,8 @@
         </p:nvSpPr>
         <p:spPr>
           <a:xfrm>
-            <a:off x="8394192" y="2240280"/>
-            <a:ext cx="3630168" cy="2743200"/>
+            <a:off x="6327648" y="2240280"/>
+            <a:ext cx="2615184" cy="2743200"/>
           </a:xfrm>
           <a:prstGeom prst="rect">
             <a:avLst/>
@@ -9475,8 +9470,8 @@
         </p:nvSpPr>
         <p:spPr>
           <a:xfrm>
-            <a:off x="8394192" y="2240280"/>
-            <a:ext cx="3630168" cy="109728"/>
+            <a:off x="6327648" y="2240280"/>
+            <a:ext cx="2615184" cy="109728"/>
           </a:xfrm>
           <a:prstGeom prst="rect">
             <a:avLst/>
@@ -9495,8 +9490,8 @@
         </p:nvSpPr>
         <p:spPr>
           <a:xfrm>
-            <a:off x="8622792" y="2514600"/>
-            <a:ext cx="3172968" cy="640080"/>
+            <a:off x="6556248" y="2514600"/>
+            <a:ext cx="2157984" cy="640080"/>
           </a:xfrm>
           <a:prstGeom prst="rect">
             <a:avLst/>
@@ -9534,8 +9529,8 @@
         </p:nvSpPr>
         <p:spPr>
           <a:xfrm>
-            <a:off x="8622792" y="3154680"/>
-            <a:ext cx="3172968" cy="640080"/>
+            <a:off x="6556248" y="3154680"/>
+            <a:ext cx="2157984" cy="640080"/>
           </a:xfrm>
           <a:prstGeom prst="rect">
             <a:avLst/>
@@ -9559,7 +9554,7 @@
                 <a:ea typeface="Segoe UI" pitchFamily="34" charset="-122"/>
                 <a:cs typeface="Segoe UI" pitchFamily="34" charset="-120"/>
               </a:rPr>
-              <a:t>Strategic reuse</a:t>
+              <a:t>Validate</a:t>
             </a:r>
             <a:endParaRPr lang="en-US" sz="1700" dirty="0"/>
           </a:p>
@@ -9573,8 +9568,8 @@
         </p:nvSpPr>
         <p:spPr>
           <a:xfrm>
-            <a:off x="8622792" y="3794760"/>
-            <a:ext cx="3172968" cy="1097280"/>
+            <a:off x="6556248" y="3794760"/>
+            <a:ext cx="2157984" cy="1097280"/>
           </a:xfrm>
           <a:prstGeom prst="rect">
             <a:avLst/>
@@ -9598,7 +9593,7 @@
                 <a:ea typeface="Segoe UI" pitchFamily="34" charset="-122"/>
                 <a:cs typeface="Segoe UI" pitchFamily="34" charset="-120"/>
               </a:rPr>
-              <a:t>Package the validation + generation engine as a reusable skill for Learn / Copilot surfaces so impact compounds.</a:t>
+              <a:t>Inspect a WAF gap and regional cost evidence.</a:t>
             </a:r>
             <a:endParaRPr lang="en-US" sz="1250" dirty="0"/>
           </a:p>
@@ -9606,14 +9601,66 @@
       </p:sp>
       <p:sp>
         <p:nvSpPr>
-          <p:cNvPr id="21" name="Text 19"/>
-          <p:cNvSpPr/>
-          <p:nvPr/>
-        </p:nvSpPr>
-        <p:spPr>
-          <a:xfrm>
-            <a:off x="548640" y="5440680"/>
-            <a:ext cx="11064240" cy="365760"/>
+          <p:cNvPr id="21" name="Shape 19"/>
+          <p:cNvSpPr/>
+          <p:nvPr/>
+        </p:nvSpPr>
+        <p:spPr>
+          <a:xfrm>
+            <a:off x="9217152" y="2240280"/>
+            <a:ext cx="2615184" cy="2743200"/>
+          </a:xfrm>
+          <a:prstGeom prst="rect">
+            <a:avLst/>
+          </a:prstGeom>
+          <a:solidFill>
+            <a:srgbClr val="102A4C"/>
+          </a:solidFill>
+          <a:ln w="12700">
+            <a:solidFill>
+              <a:srgbClr val="1F3A5C"/>
+            </a:solidFill>
+            <a:prstDash val="solid"/>
+          </a:ln>
+          <a:effectLst>
+            <a:outerShdw sx="100000" sy="100000" kx="0" ky="0" algn="bl" rotWithShape="0" blurRad="114300" dist="38100" dir="5400000">
+              <a:srgbClr val="0A1422">
+                <a:alpha val="18000"/>
+              </a:srgbClr>
+            </a:outerShdw>
+          </a:effectLst>
+        </p:spPr>
+      </p:sp>
+      <p:sp>
+        <p:nvSpPr>
+          <p:cNvPr id="22" name="Shape 20"/>
+          <p:cNvSpPr/>
+          <p:nvPr/>
+        </p:nvSpPr>
+        <p:spPr>
+          <a:xfrm>
+            <a:off x="9217152" y="2240280"/>
+            <a:ext cx="2615184" cy="109728"/>
+          </a:xfrm>
+          <a:prstGeom prst="rect">
+            <a:avLst/>
+          </a:prstGeom>
+          <a:solidFill>
+            <a:srgbClr val="3FB950"/>
+          </a:solidFill>
+          <a:ln/>
+        </p:spPr>
+      </p:sp>
+      <p:sp>
+        <p:nvSpPr>
+          <p:cNvPr id="23" name="Text 21"/>
+          <p:cNvSpPr/>
+          <p:nvPr/>
+        </p:nvSpPr>
+        <p:spPr>
+          <a:xfrm>
+            <a:off x="9445752" y="2514600"/>
+            <a:ext cx="2157984" cy="640080"/>
           </a:xfrm>
           <a:prstGeom prst="rect">
             <a:avLst/>
@@ -9625,27 +9672,144 @@
           <a:bodyPr wrap="square" lIns="0" tIns="0" rIns="0" bIns="0" rtlCol="0" anchor="ctr"/>
           <a:lstStyle/>
           <a:p>
+            <a:pPr indent="0" marL="0">
+              <a:buNone/>
+            </a:pPr>
+            <a:r>
+              <a:rPr lang="en-US" sz="2800" b="1" dirty="0">
+                <a:solidFill>
+                  <a:srgbClr val="3FB950"/>
+                </a:solidFill>
+                <a:latin typeface="Segoe UI" pitchFamily="34" charset="0"/>
+                <a:ea typeface="Segoe UI" pitchFamily="34" charset="-122"/>
+                <a:cs typeface="Segoe UI" pitchFamily="34" charset="-120"/>
+              </a:rPr>
+              <a:t>04</a:t>
+            </a:r>
+            <a:endParaRPr lang="en-US" sz="2800" dirty="0"/>
+          </a:p>
+        </p:txBody>
+      </p:sp>
+      <p:sp>
+        <p:nvSpPr>
+          <p:cNvPr id="24" name="Text 22"/>
+          <p:cNvSpPr/>
+          <p:nvPr/>
+        </p:nvSpPr>
+        <p:spPr>
+          <a:xfrm>
+            <a:off x="9445752" y="3154680"/>
+            <a:ext cx="2157984" cy="640080"/>
+          </a:xfrm>
+          <a:prstGeom prst="rect">
+            <a:avLst/>
+          </a:prstGeom>
+          <a:noFill/>
+          <a:ln/>
+        </p:spPr>
+        <p:txBody>
+          <a:bodyPr wrap="square" lIns="0" tIns="0" rIns="0" bIns="0" rtlCol="0" anchor="t"/>
+          <a:lstStyle/>
+          <a:p>
+            <a:pPr indent="0" marL="0">
+              <a:buNone/>
+            </a:pPr>
+            <a:r>
+              <a:rPr lang="en-US" sz="1700" b="1" dirty="0">
+                <a:solidFill>
+                  <a:srgbClr val="FFFFFF"/>
+                </a:solidFill>
+                <a:latin typeface="Segoe UI" pitchFamily="34" charset="0"/>
+                <a:ea typeface="Segoe UI" pitchFamily="34" charset="-122"/>
+                <a:cs typeface="Segoe UI" pitchFamily="34" charset="-120"/>
+              </a:rPr>
+              <a:t>Deliver</a:t>
+            </a:r>
+            <a:endParaRPr lang="en-US" sz="1700" dirty="0"/>
+          </a:p>
+        </p:txBody>
+      </p:sp>
+      <p:sp>
+        <p:nvSpPr>
+          <p:cNvPr id="25" name="Text 23"/>
+          <p:cNvSpPr/>
+          <p:nvPr/>
+        </p:nvSpPr>
+        <p:spPr>
+          <a:xfrm>
+            <a:off x="9445752" y="3794760"/>
+            <a:ext cx="2157984" cy="1097280"/>
+          </a:xfrm>
+          <a:prstGeom prst="rect">
+            <a:avLst/>
+          </a:prstGeom>
+          <a:noFill/>
+          <a:ln/>
+        </p:spPr>
+        <p:txBody>
+          <a:bodyPr wrap="square" lIns="0" tIns="0" rIns="0" bIns="0" rtlCol="0" anchor="t"/>
+          <a:lstStyle/>
+          <a:p>
+            <a:pPr indent="0" marL="0">
+              <a:buNone/>
+            </a:pPr>
+            <a:r>
+              <a:rPr lang="en-US" sz="1250" dirty="0">
+                <a:solidFill>
+                  <a:srgbClr val="B9CAE3"/>
+                </a:solidFill>
+                <a:latin typeface="Segoe UI" pitchFamily="34" charset="0"/>
+                <a:ea typeface="Segoe UI" pitchFamily="34" charset="-122"/>
+                <a:cs typeface="Segoe UI" pitchFamily="34" charset="-120"/>
+              </a:rPr>
+              <a:t>Export a deck or call the same design logic through MCP.</a:t>
+            </a:r>
+            <a:endParaRPr lang="en-US" sz="1250" dirty="0"/>
+          </a:p>
+        </p:txBody>
+      </p:sp>
+      <p:sp>
+        <p:nvSpPr>
+          <p:cNvPr id="26" name="Text 24"/>
+          <p:cNvSpPr/>
+          <p:nvPr/>
+        </p:nvSpPr>
+        <p:spPr>
+          <a:xfrm>
+            <a:off x="548640" y="5413248"/>
+            <a:ext cx="11064240" cy="420624"/>
+          </a:xfrm>
+          <a:prstGeom prst="rect">
+            <a:avLst/>
+          </a:prstGeom>
+          <a:noFill/>
+          <a:ln/>
+        </p:spPr>
+        <p:txBody>
+          <a:bodyPr wrap="square" lIns="0" tIns="0" rIns="0" bIns="0" rtlCol="0" anchor="ctr"/>
+          <a:lstStyle/>
+          <a:p>
             <a:pPr algn="ctr" indent="0" marL="0">
               <a:buNone/>
             </a:pPr>
             <a:r>
-              <a:rPr lang="en-US" sz="1200" i="1" dirty="0">
-                <a:solidFill>
-                  <a:srgbClr val="7E93B4"/>
-                </a:solidFill>
-                <a:latin typeface="Segoe UI" pitchFamily="34" charset="0"/>
-                <a:ea typeface="Segoe UI" pitchFamily="34" charset="-122"/>
-                <a:cs typeface="Segoe UI" pitchFamily="34" charset="-120"/>
-              </a:rPr>
-              <a:t>Reproduce the numbers anytime:  ./scripts/usage-report.sh 120   ·   python3 scripts/llm-cost-report.py --days 30</a:t>
-            </a:r>
-            <a:endParaRPr lang="en-US" sz="1200" dirty="0"/>
-          </a:p>
-        </p:txBody>
-      </p:sp>
-      <p:sp>
-        <p:nvSpPr>
-          <p:cNvPr id="22" name="Text 20"/>
+              <a:rPr lang="en-US" sz="1400" b="1" dirty="0">
+                <a:solidFill>
+                  <a:srgbClr val="AFC3DF"/>
+                </a:solidFill>
+                <a:latin typeface="Segoe UI" pitchFamily="34" charset="0"/>
+                <a:ea typeface="Segoe UI" pitchFamily="34" charset="-122"/>
+                <a:cs typeface="Segoe UI" pitchFamily="34" charset="-120"/>
+              </a:rPr>
+              <a:t>Try it:  aka.ms/diagram-builder   ·   Current production version: v2.0.4</a:t>
+            </a:r>
+            <a:endParaRPr lang="en-US" sz="1400" dirty="0"/>
+          </a:p>
+        </p:txBody>
+      </p:sp>
+      <p:sp>
+        <p:nvSpPr>
+          <p:cNvPr id="27" name="Text 25"/>
           <p:cNvSpPr/>
           <p:nvPr/>
         </p:nvSpPr>
@@ -9668,9 +9832,9 @@
               <a:buNone/>
             </a:pPr>
             <a:r>
-              <a:rPr lang="en-US" sz="900" dirty="0">
-                <a:solidFill>
-                  <a:srgbClr val="5E7799"/>
+              <a:rPr lang="en-US" sz="1000" dirty="0">
+                <a:solidFill>
+                  <a:srgbClr val="9BB0CC"/>
                 </a:solidFill>
                 <a:latin typeface="Segoe UI" pitchFamily="34" charset="0"/>
                 <a:ea typeface="Segoe UI" pitchFamily="34" charset="-122"/>
@@ -9678,13 +9842,13 @@
               </a:rPr>
               <a:t>Azure Architecture Diagram Builder</a:t>
             </a:r>
-            <a:endParaRPr lang="en-US" sz="900" dirty="0"/>
-          </a:p>
-        </p:txBody>
-      </p:sp>
-      <p:sp>
-        <p:nvSpPr>
-          <p:cNvPr id="23" name="Text 21"/>
+            <a:endParaRPr lang="en-US" sz="1000" dirty="0"/>
+          </a:p>
+        </p:txBody>
+      </p:sp>
+      <p:sp>
+        <p:nvSpPr>
+          <p:cNvPr id="28" name="Text 26"/>
           <p:cNvSpPr/>
           <p:nvPr/>
         </p:nvSpPr>
@@ -9707,9 +9871,9 @@
               <a:buNone/>
             </a:pPr>
             <a:r>
-              <a:rPr lang="en-US" sz="900" dirty="0">
-                <a:solidFill>
-                  <a:srgbClr val="5E7799"/>
+              <a:rPr lang="en-US" sz="1000" dirty="0">
+                <a:solidFill>
+                  <a:srgbClr val="9BB0CC"/>
                 </a:solidFill>
                 <a:latin typeface="Segoe UI" pitchFamily="34" charset="0"/>
                 <a:ea typeface="Segoe UI" pitchFamily="34" charset="-122"/>
@@ -9717,7 +9881,7 @@
               </a:rPr>
               <a:t>9</a:t>
             </a:r>
-            <a:endParaRPr lang="en-US" sz="900" dirty="0"/>
+            <a:endParaRPr lang="en-US" sz="1000" dirty="0"/>
           </a:p>
         </p:txBody>
       </p:sp>

</xml_diff>